<commit_message>
group names with student numbers
</commit_message>
<xml_diff>
--- a/tools/demo/presentation.pptx
+++ b/tools/demo/presentation.pptx
@@ -1698,7 +1698,29 @@
                 <a:ea typeface="Calibri" pitchFamily="34" charset="-122"/>
                 <a:cs typeface="Calibri" pitchFamily="34" charset="-120"/>
               </a:rPr>
-              <a:t>Zaid Ismail (1696814)</a:t>
+              <a:t>Zaid Ismail </a:t>
+            </a:r>
+            <a:r>
+              <a:rPr lang="en-US" sz="1600">
+                <a:solidFill>
+                  <a:srgbClr val="FFFFFF"/>
+                </a:solidFill>
+                <a:latin typeface="Calibri" pitchFamily="34" charset="0"/>
+                <a:ea typeface="Calibri" pitchFamily="34" charset="-122"/>
+                <a:cs typeface="Calibri" pitchFamily="34" charset="-120"/>
+              </a:rPr>
+              <a:t>(1695814</a:t>
+            </a:r>
+            <a:r>
+              <a:rPr lang="en-US" sz="1600" dirty="0">
+                <a:solidFill>
+                  <a:srgbClr val="FFFFFF"/>
+                </a:solidFill>
+                <a:latin typeface="Calibri" pitchFamily="34" charset="0"/>
+                <a:ea typeface="Calibri" pitchFamily="34" charset="-122"/>
+                <a:cs typeface="Calibri" pitchFamily="34" charset="-120"/>
+              </a:rPr>
+              <a:t>)</a:t>
             </a:r>
             <a:endParaRPr lang="en-US" sz="1600" dirty="0"/>
           </a:p>

</xml_diff>